<commit_message>
Verify P0-15 frozen two-object revisions across both deck paths
</commit_message>
<xml_diff>
--- a/docs/product/ppt-benchmark-materials/PPT-P0-15/wiswork-generated-candidate.pptx
+++ b/docs/product/ppt-benchmark-materials/PPT-P0-15/wiswork-generated-candidate.pptx
@@ -1257,6 +1257,7 @@
 来源：Deardorff et al., PLOS ONE 2020；本稿为待审候选。
 [source-1] Deardorff et al., PLOS ONE 2020, doi:10.1371/journal.pone.0230697 · 第 1 页
 论文研究事实仍待人工审阅
+Image [participant-illustration]: WisWork 自制示意图 07; license: owned; alt text: missing
 Attribution supplied by the input; source accuracy and license rights have not been independently verified.</a:t>
             </a:r>
             <a:endParaRPr lang="en-US" dirty="0"/>
@@ -2679,9 +2680,33 @@
           </a:p>
         </p:txBody>
       </p:sp>
-      <p:sp>
-        <p:nvSpPr>
-          <p:cNvPr id="5" name="left-caption"/>
+      <p:pic>
+        <p:nvPicPr>
+          <p:cNvPr id="5" name="participant-image" descr="Image description missing">    </p:cNvPr>
+          <p:cNvPicPr>
+            <a:picLocks noChangeAspect="1"/>
+          </p:cNvPicPr>
+          <p:nvPr/>
+        </p:nvPicPr>
+        <p:blipFill>
+          <a:blip r:embed="rId1"/>
+          <a:stretch>
+            <a:fillRect/>
+          </a:stretch>
+        </p:blipFill>
+        <p:spPr>
+          <a:xfrm>
+            <a:off x="1910080" y="3703320"/>
+            <a:ext cx="2763520" cy="1554480"/>
+          </a:xfrm>
+          <a:prstGeom prst="rect">
+            <a:avLst/>
+          </a:prstGeom>
+        </p:spPr>
+      </p:pic>
+      <p:sp>
+        <p:nvSpPr>
+          <p:cNvPr id="6" name="left-caption"/>
           <p:cNvSpPr/>
           <p:nvPr/>
         </p:nvSpPr>
@@ -2720,7 +2745,7 @@
       </p:sp>
       <p:sp>
         <p:nvSpPr>
-          <p:cNvPr id="6" name="source-attribution"/>
+          <p:cNvPr id="7" name="source-attribution"/>
           <p:cNvSpPr/>
           <p:nvPr/>
         </p:nvSpPr>

</xml_diff>

<commit_message>
Add source-backed P0-15 generated edit-path candidate
</commit_message>
<xml_diff>
--- a/docs/product/ppt-benchmark-materials/PPT-P0-15/wiswork-generated-candidate.pptx
+++ b/docs/product/ppt-benchmark-materials/PPT-P0-15/wiswork-generated-candidate.pptx
@@ -148,7 +148,7 @@
           </c:spPr>
           <c:invertIfNegative val="0"/>
           <c:dLbls>
-            <c:numFmt formatCode="#,##0" sourceLinked="0"/>
+            <c:numFmt formatCode="#,##0.########" sourceLinked="0"/>
             <c:txPr>
               <a:bodyPr/>
               <a:lstStyle/>
@@ -156,9 +156,9 @@
                 <a:pPr>
                   <a:defRPr b="0" i="0" strike="noStrike" sz="1200" u="none">
                     <a:solidFill>
-                      <a:srgbClr val="000000"/>
+                      <a:srgbClr val="122B43"/>
                     </a:solidFill>
-                    <a:latin typeface="Arial"/>
+                    <a:latin typeface="Noto Sans CJK SC"/>
                   </a:defRPr>
                 </a:pPr>
               </a:p>
@@ -204,7 +204,7 @@
           </c:val>
         </c:ser>
         <c:dLbls>
-          <c:numFmt formatCode="#,##0" sourceLinked="0"/>
+          <c:numFmt formatCode="#,##0.########" sourceLinked="0"/>
           <c:txPr>
             <a:bodyPr/>
             <a:lstStyle/>
@@ -212,9 +212,9 @@
               <a:pPr>
                 <a:defRPr b="0" i="0" strike="noStrike" sz="1200" u="none">
                   <a:solidFill>
-                    <a:srgbClr val="000000"/>
+                    <a:srgbClr val="122B43"/>
                   </a:solidFill>
-                  <a:latin typeface="Arial"/>
+                  <a:latin typeface="Noto Sans CJK SC"/>
                 </a:defRPr>
               </a:pPr>
             </a:p>
@@ -247,7 +247,7 @@
         <c:spPr>
           <a:ln w="12700" cap="flat">
             <a:solidFill>
-              <a:srgbClr val="888888"/>
+              <a:srgbClr val="122B43"/>
             </a:solidFill>
             <a:prstDash val="solid"/>
             <a:round/>
@@ -260,7 +260,7 @@
             <a:pPr>
               <a:defRPr sz="1200" b="0" i="0" u="none" strike="noStrike">
                 <a:solidFill>
-                  <a:srgbClr val="000000"/>
+                  <a:srgbClr val="122B43"/>
                 </a:solidFill>
                 <a:latin typeface="Noto Sans CJK SC"/>
               </a:defRPr>
@@ -278,6 +278,7 @@
         <c:axId val="2094734552"/>
         <c:scaling>
           <c:orientation val="minMax"/>
+          <c:min val="0"/>
         </c:scaling>
         <c:delete val="0"/>
         <c:axPos val="l"/>
@@ -285,7 +286,7 @@
           <c:spPr>
             <a:ln w="12700" cap="flat">
               <a:solidFill>
-                <a:srgbClr val="888888"/>
+                <a:srgbClr val="122B43"/>
               </a:solidFill>
               <a:prstDash val="solid"/>
               <a:round/>
@@ -299,7 +300,7 @@
         <c:spPr>
           <a:ln w="12700" cap="flat">
             <a:solidFill>
-              <a:srgbClr val="888888"/>
+              <a:srgbClr val="122B43"/>
             </a:solidFill>
             <a:prstDash val="solid"/>
             <a:round/>
@@ -312,7 +313,7 @@
             <a:pPr>
               <a:defRPr sz="1200" b="0" i="0" u="none" strike="noStrike">
                 <a:solidFill>
-                  <a:srgbClr val="000000"/>
+                  <a:srgbClr val="122B43"/>
                 </a:solidFill>
                 <a:latin typeface="Noto Sans CJK SC"/>
               </a:defRPr>
@@ -325,7 +326,9 @@
         <c:crossBetween val="between"/>
       </c:valAx>
       <c:spPr>
-        <a:noFill/>
+        <a:solidFill>
+          <a:srgbClr val="FFFFFF"/>
+        </a:solidFill>
         <a:ln>
           <a:noFill/>
         </a:ln>
@@ -336,7 +339,9 @@
     <c:dispBlanksAs val="span"/>
   </c:chart>
   <c:spPr>
-    <a:noFill/>
+    <a:solidFill>
+      <a:srgbClr val="FFFFFF"/>
+    </a:solidFill>
     <a:ln>
       <a:noFill/>
     </a:ln>
@@ -382,7 +387,7 @@
           </c:spPr>
           <c:invertIfNegative val="0"/>
           <c:dLbls>
-            <c:numFmt formatCode="#,##0" sourceLinked="0"/>
+            <c:numFmt formatCode="#,##0.########" sourceLinked="0"/>
             <c:txPr>
               <a:bodyPr/>
               <a:lstStyle/>
@@ -390,9 +395,9 @@
                 <a:pPr>
                   <a:defRPr b="0" i="0" strike="noStrike" sz="1200" u="none">
                     <a:solidFill>
-                      <a:srgbClr val="000000"/>
+                      <a:srgbClr val="122B43"/>
                     </a:solidFill>
-                    <a:latin typeface="Arial"/>
+                    <a:latin typeface="Noto Sans CJK SC"/>
                   </a:defRPr>
                 </a:pPr>
               </a:p>
@@ -438,7 +443,7 @@
           </c:val>
         </c:ser>
         <c:dLbls>
-          <c:numFmt formatCode="#,##0" sourceLinked="0"/>
+          <c:numFmt formatCode="#,##0.########" sourceLinked="0"/>
           <c:txPr>
             <a:bodyPr/>
             <a:lstStyle/>
@@ -446,9 +451,9 @@
               <a:pPr>
                 <a:defRPr b="0" i="0" strike="noStrike" sz="1200" u="none">
                   <a:solidFill>
-                    <a:srgbClr val="000000"/>
+                    <a:srgbClr val="122B43"/>
                   </a:solidFill>
-                  <a:latin typeface="Arial"/>
+                  <a:latin typeface="Noto Sans CJK SC"/>
                 </a:defRPr>
               </a:pPr>
             </a:p>
@@ -481,7 +486,7 @@
         <c:spPr>
           <a:ln w="12700" cap="flat">
             <a:solidFill>
-              <a:srgbClr val="888888"/>
+              <a:srgbClr val="122B43"/>
             </a:solidFill>
             <a:prstDash val="solid"/>
             <a:round/>
@@ -494,7 +499,7 @@
             <a:pPr>
               <a:defRPr sz="1200" b="0" i="0" u="none" strike="noStrike">
                 <a:solidFill>
-                  <a:srgbClr val="000000"/>
+                  <a:srgbClr val="122B43"/>
                 </a:solidFill>
                 <a:latin typeface="Noto Sans CJK SC"/>
               </a:defRPr>
@@ -512,6 +517,7 @@
         <c:axId val="2094734552"/>
         <c:scaling>
           <c:orientation val="minMax"/>
+          <c:min val="0"/>
         </c:scaling>
         <c:delete val="0"/>
         <c:axPos val="l"/>
@@ -519,7 +525,7 @@
           <c:spPr>
             <a:ln w="12700" cap="flat">
               <a:solidFill>
-                <a:srgbClr val="888888"/>
+                <a:srgbClr val="122B43"/>
               </a:solidFill>
               <a:prstDash val="solid"/>
               <a:round/>
@@ -533,7 +539,7 @@
         <c:spPr>
           <a:ln w="12700" cap="flat">
             <a:solidFill>
-              <a:srgbClr val="888888"/>
+              <a:srgbClr val="122B43"/>
             </a:solidFill>
             <a:prstDash val="solid"/>
             <a:round/>
@@ -546,7 +552,7 @@
             <a:pPr>
               <a:defRPr sz="1200" b="0" i="0" u="none" strike="noStrike">
                 <a:solidFill>
-                  <a:srgbClr val="000000"/>
+                  <a:srgbClr val="122B43"/>
                 </a:solidFill>
                 <a:latin typeface="Noto Sans CJK SC"/>
               </a:defRPr>
@@ -559,7 +565,9 @@
         <c:crossBetween val="between"/>
       </c:valAx>
       <c:spPr>
-        <a:noFill/>
+        <a:solidFill>
+          <a:srgbClr val="FFFFFF"/>
+        </a:solidFill>
         <a:ln>
           <a:noFill/>
         </a:ln>
@@ -570,7 +578,9 @@
     <c:dispBlanksAs val="span"/>
   </c:chart>
   <c:spPr>
-    <a:noFill/>
+    <a:solidFill>
+      <a:srgbClr val="FFFFFF"/>
+    </a:solidFill>
     <a:ln>
       <a:noFill/>
     </a:ln>
@@ -979,8 +989,6 @@
               <a:rPr lang="en-US" dirty="0"/>
               <a:t>计算可复现性工作坊：研究汇报
 来源：Deardorff et al., PLOS ONE 2020；本稿为待审候选。
-[source-1] Deardorff et al., PLOS ONE 2020, doi:10.1371/journal.pone.0230697 · 第 1 页
-论文研究事实仍待人工审阅
 Attribution supplied by the input; source accuracy and license rights have not been independently verified.</a:t>
             </a:r>
             <a:endParaRPr lang="en-US" dirty="0"/>
@@ -1071,8 +1079,6 @@
               <a:rPr lang="en-US" dirty="0"/>
               <a:t>研究问题与汇报范围
 来源：Deardorff et al., PLOS ONE 2020；本稿为待审候选。
-[source-1] Deardorff et al., PLOS ONE 2020, doi:10.1371/journal.pone.0230697 · 第 1 页
-论文研究事实仍待人工审阅
 Attribution supplied by the input; source accuracy and license rights have not been independently verified.</a:t>
             </a:r>
             <a:endParaRPr lang="en-US" dirty="0"/>
@@ -1163,8 +1169,8 @@
               <a:rPr lang="en-US" dirty="0"/>
               <a:t>研究方法与时间点
 来源：Deardorff et al., PLOS ONE 2020；本稿为待审候选。
-[source-1] Deardorff et al., PLOS ONE 2020, doi:10.1371/journal.pone.0230697 · 第 1 页
-论文研究事实仍待人工审阅
+[sample] https://doi.org/10.1371/journal.pone.0230697 ; https://doi.org/10.1371/journal.pone.0230697 · PDF 1 methods ; PDF 5 sample
+工作坊前访谈 14 人，三个月后完成访谈 12 人；两时点分母不同。
 Attribution supplied by the input; source accuracy and license rights have not been independently verified.</a:t>
             </a:r>
             <a:endParaRPr lang="en-US" dirty="0"/>
@@ -1255,9 +1261,9 @@
               <a:rPr lang="en-US" dirty="0"/>
               <a:t>参与者与证据路径
 来源：Deardorff et al., PLOS ONE 2020；本稿为待审候选。
-[source-1] Deardorff et al., PLOS ONE 2020, doi:10.1371/journal.pone.0230697 · 第 1 页
-论文研究事实仍待人工审阅
-Image [participant-illustration]: WisWork 自制示意图 07; license: owned; alt text: missing
+[illustration] local:asset-rights.json · P0-13-IMG-07
+第 4 页自制示意图不是论文测量数据，权利来自本包声明。
+Image [participant-illustration]: WisWork 自制示意图 07; license: owned; alt text: 自制示意图 07：招募、工作坊与三个月后访谈；非研究测量数据
 Attribution supplied by the input; source accuracy and license rights have not been independently verified.</a:t>
             </a:r>
             <a:endParaRPr lang="en-US" dirty="0"/>
@@ -1348,8 +1354,8 @@
               <a:rPr lang="en-US" dirty="0"/>
               <a:t>六项清单均值
 来源：Deardorff et al., PLOS ONE 2020；本稿为待审候选。
-[source-1] Deardorff et al., PLOS ONE 2020, doi:10.1371/journal.pone.0230697 · 第 1 页
-论文研究事实仍待人工审阅
+[score] https://doi.org/10.1371/journal.pone.0230697 · PDF 5 checklist
+六项清单均值从 1.6/6 到 2.2/6，p=0.318，未达统计显著。
 Attribution supplied by the input; source accuracy and license rights have not been independently verified.</a:t>
             </a:r>
             <a:endParaRPr lang="en-US" dirty="0"/>
@@ -1440,8 +1446,8 @@
               <a:rPr lang="en-US" dirty="0"/>
               <a:t>开源软件使用：不同分母
 来源：Deardorff et al., PLOS ONE 2020；本稿为待审候选。
-[source-1] Deardorff et al., PLOS ONE 2020, doi:10.1371/journal.pone.0230697 · 第 1 页
-论文研究事实仍待人工审阅
+[open-source] https://doi.org/10.1371/journal.pone.0230697 ; https://doi.org/10.1371/journal.pone.0230697 · PDF 5 Table 1 ; PDF 5 sample
+开源软件使用人数前测 7/14、后测 10/12；分母不同。
 Attribution supplied by the input; source accuracy and license rights have not been independently verified.</a:t>
             </a:r>
             <a:endParaRPr lang="en-US" dirty="0"/>
@@ -1532,8 +1538,8 @@
               <a:rPr lang="en-US" dirty="0"/>
               <a:t>解释边界与局限
 来源：Deardorff et al., PLOS ONE 2020；本稿为待审候选。
-[source-1] Deardorff et al., PLOS ONE 2020, doi:10.1371/journal.pone.0230697 · 第 1 页
-论文研究事实仍待人工审阅
+[limitations] https://doi.org/10.1371/journal.pone.0230697 · PDF 9 limitations
+小样本、招募与应答偏差、单人编码和统计功效不足限制推断。
 Attribution supplied by the input; source accuracy and license rights have not been independently verified.</a:t>
             </a:r>
             <a:endParaRPr lang="en-US" dirty="0"/>
@@ -1624,8 +1630,8 @@
               <a:rPr lang="en-US" dirty="0"/>
               <a:t>结论与后续审阅
 来源：Deardorff et al., PLOS ONE 2020；本稿为待审候选。
-[source-1] Deardorff et al., PLOS ONE 2020, doi:10.1371/journal.pone.0230697 · 第 1 页
-论文研究事实仍待人工审阅
+[limitations] https://doi.org/10.1371/journal.pone.0230697 · PDF 9 limitations
+小样本、招募与应答偏差、单人编码和统计功效不足限制推断。
 Attribution supplied by the input; source accuracy and license rights have not been independently verified.</a:t>
             </a:r>
             <a:endParaRPr lang="en-US" dirty="0"/>
@@ -2085,7 +2091,7 @@
         </p:nvSpPr>
         <p:spPr>
           <a:xfrm>
-            <a:off x="777240" y="6355080"/>
+            <a:off x="777240" y="6053328"/>
             <a:ext cx="10424160" cy="228600"/>
           </a:xfrm>
           <a:prstGeom prst="rect">
@@ -2113,45 +2119,6 @@
               <a:t>来源：Deardorff et al., PLOS ONE 2020；待科研审阅</a:t>
             </a:r>
             <a:endParaRPr lang="en-US" sz="900" dirty="0"/>
-          </a:p>
-        </p:txBody>
-      </p:sp>
-      <p:sp>
-        <p:nvSpPr>
-          <p:cNvPr id="5" name="source-attribution"/>
-          <p:cNvSpPr/>
-          <p:nvPr/>
-        </p:nvSpPr>
-        <p:spPr>
-          <a:xfrm>
-            <a:off x="457200" y="6446520"/>
-            <a:ext cx="11247120" cy="274320"/>
-          </a:xfrm>
-          <a:prstGeom prst="rect">
-            <a:avLst/>
-          </a:prstGeom>
-          <a:noFill/>
-          <a:ln/>
-        </p:spPr>
-        <p:txBody>
-          <a:bodyPr wrap="square" lIns="0" tIns="0" rIns="0" bIns="0" rtlCol="0" anchor="ctr"/>
-          <a:lstStyle/>
-          <a:p>
-            <a:pPr indent="0" marL="0">
-              <a:buNone/>
-            </a:pPr>
-            <a:r>
-              <a:rPr lang="en-US" sz="800" dirty="0">
-                <a:solidFill>
-                  <a:srgbClr val="122B43"/>
-                </a:solidFill>
-                <a:latin typeface="Noto Sans CJK SC" pitchFamily="34" charset="0"/>
-                <a:ea typeface="Noto Sans CJK SC" pitchFamily="34" charset="-122"/>
-                <a:cs typeface="Noto Sans CJK SC" pitchFamily="34" charset="-120"/>
-              </a:rPr>
-              <a:t>[source-1] Deardorff et al., PLOS ONE 2020, doi:10.1371/journal.pone.0230697 · 第 1 页</a:t>
-            </a:r>
-            <a:endParaRPr lang="en-US" sz="800" dirty="0"/>
           </a:p>
         </p:txBody>
       </p:sp>
@@ -2273,7 +2240,7 @@
         </p:nvSpPr>
         <p:spPr>
           <a:xfrm>
-            <a:off x="777240" y="6355080"/>
+            <a:off x="777240" y="6053328"/>
             <a:ext cx="10424160" cy="228600"/>
           </a:xfrm>
           <a:prstGeom prst="rect">
@@ -2301,45 +2268,6 @@
               <a:t>来源：Deardorff et al., PLOS ONE 2020；待科研审阅</a:t>
             </a:r>
             <a:endParaRPr lang="en-US" sz="900" dirty="0"/>
-          </a:p>
-        </p:txBody>
-      </p:sp>
-      <p:sp>
-        <p:nvSpPr>
-          <p:cNvPr id="5" name="source-attribution"/>
-          <p:cNvSpPr/>
-          <p:nvPr/>
-        </p:nvSpPr>
-        <p:spPr>
-          <a:xfrm>
-            <a:off x="457200" y="6446520"/>
-            <a:ext cx="11247120" cy="274320"/>
-          </a:xfrm>
-          <a:prstGeom prst="rect">
-            <a:avLst/>
-          </a:prstGeom>
-          <a:noFill/>
-          <a:ln/>
-        </p:spPr>
-        <p:txBody>
-          <a:bodyPr wrap="square" lIns="0" tIns="0" rIns="0" bIns="0" rtlCol="0" anchor="ctr"/>
-          <a:lstStyle/>
-          <a:p>
-            <a:pPr indent="0" marL="0">
-              <a:buNone/>
-            </a:pPr>
-            <a:r>
-              <a:rPr lang="en-US" sz="800" dirty="0">
-                <a:solidFill>
-                  <a:srgbClr val="122B43"/>
-                </a:solidFill>
-                <a:latin typeface="Noto Sans CJK SC" pitchFamily="34" charset="0"/>
-                <a:ea typeface="Noto Sans CJK SC" pitchFamily="34" charset="-122"/>
-                <a:cs typeface="Noto Sans CJK SC" pitchFamily="34" charset="-120"/>
-              </a:rPr>
-              <a:t>[source-1] Deardorff et al., PLOS ONE 2020, doi:10.1371/journal.pone.0230697 · 第 1 页</a:t>
-            </a:r>
-            <a:endParaRPr lang="en-US" sz="800" dirty="0"/>
           </a:p>
         </p:txBody>
       </p:sp>
@@ -2461,7 +2389,7 @@
         </p:nvSpPr>
         <p:spPr>
           <a:xfrm>
-            <a:off x="777240" y="6355080"/>
+            <a:off x="777240" y="6053328"/>
             <a:ext cx="10424160" cy="228600"/>
           </a:xfrm>
           <a:prstGeom prst="rect">
@@ -2510,10 +2438,10 @@
           <a:ln/>
         </p:spPr>
         <p:txBody>
-          <a:bodyPr wrap="square" lIns="0" tIns="0" rIns="0" bIns="0" rtlCol="0" anchor="ctr"/>
-          <a:lstStyle/>
-          <a:p>
-            <a:pPr indent="0" marL="0">
+          <a:bodyPr wrap="square" lIns="0" tIns="0" rIns="0" bIns="0" rtlCol="0" anchor="t"/>
+          <a:lstStyle/>
+          <a:p>
+            <a:pPr algn="l" indent="0" marL="0">
               <a:buNone/>
             </a:pPr>
             <a:r>
@@ -2525,7 +2453,7 @@
                 <a:ea typeface="Noto Sans CJK SC" pitchFamily="34" charset="-122"/>
                 <a:cs typeface="Noto Sans CJK SC" pitchFamily="34" charset="-120"/>
               </a:rPr>
-              <a:t>[source-1] Deardorff et al., PLOS ONE 2020, doi:10.1371/journal.pone.0230697 · 第 1 页</a:t>
+              <a:t>[sample] https://doi.org/10.1371/journal.pone.0230697 ; https://doi.org/10.1371/journal.pone.0230697 · PDF 1 methods ; PDF 5 sample</a:t>
             </a:r>
             <a:endParaRPr lang="en-US" sz="800" dirty="0"/>
           </a:p>
@@ -2649,7 +2577,7 @@
         </p:nvSpPr>
         <p:spPr>
           <a:xfrm>
-            <a:off x="777240" y="6355080"/>
+            <a:off x="777240" y="6053328"/>
             <a:ext cx="10424160" cy="228600"/>
           </a:xfrm>
           <a:prstGeom prst="rect">
@@ -2682,7 +2610,7 @@
       </p:sp>
       <p:pic>
         <p:nvPicPr>
-          <p:cNvPr id="5" name="participant-image" descr="Image description missing">    </p:cNvPr>
+          <p:cNvPr id="5" name="participant-image" descr="自制示意图 07：招募、工作坊与三个月后访谈；非研究测量数据">    </p:cNvPr>
           <p:cNvPicPr>
             <a:picLocks noChangeAspect="1"/>
           </p:cNvPicPr>
@@ -2761,10 +2689,10 @@
           <a:ln/>
         </p:spPr>
         <p:txBody>
-          <a:bodyPr wrap="square" lIns="0" tIns="0" rIns="0" bIns="0" rtlCol="0" anchor="ctr"/>
-          <a:lstStyle/>
-          <a:p>
-            <a:pPr indent="0" marL="0">
+          <a:bodyPr wrap="square" lIns="0" tIns="0" rIns="0" bIns="0" rtlCol="0" anchor="t"/>
+          <a:lstStyle/>
+          <a:p>
+            <a:pPr algn="l" indent="0" marL="0">
               <a:buNone/>
             </a:pPr>
             <a:r>
@@ -2776,7 +2704,7 @@
                 <a:ea typeface="Noto Sans CJK SC" pitchFamily="34" charset="-122"/>
                 <a:cs typeface="Noto Sans CJK SC" pitchFamily="34" charset="-120"/>
               </a:rPr>
-              <a:t>[source-1] Deardorff et al., PLOS ONE 2020, doi:10.1371/journal.pone.0230697 · 第 1 页</a:t>
+              <a:t>[illustration] local:asset-rights.json · P0-13-IMG-07</a:t>
             </a:r>
             <a:endParaRPr lang="en-US" sz="800" dirty="0"/>
           </a:p>
@@ -2900,7 +2828,7 @@
         </p:nvSpPr>
         <p:spPr>
           <a:xfrm>
-            <a:off x="777240" y="6355080"/>
+            <a:off x="777240" y="6053328"/>
             <a:ext cx="10424160" cy="228600"/>
           </a:xfrm>
           <a:prstGeom prst="rect">
@@ -2965,10 +2893,10 @@
           <a:ln/>
         </p:spPr>
         <p:txBody>
-          <a:bodyPr wrap="square" lIns="0" tIns="0" rIns="0" bIns="0" rtlCol="0" anchor="ctr"/>
-          <a:lstStyle/>
-          <a:p>
-            <a:pPr indent="0" marL="0">
+          <a:bodyPr wrap="square" lIns="0" tIns="0" rIns="0" bIns="0" rtlCol="0" anchor="t"/>
+          <a:lstStyle/>
+          <a:p>
+            <a:pPr algn="l" indent="0" marL="0">
               <a:buNone/>
             </a:pPr>
             <a:r>
@@ -2980,7 +2908,7 @@
                 <a:ea typeface="Noto Sans CJK SC" pitchFamily="34" charset="-122"/>
                 <a:cs typeface="Noto Sans CJK SC" pitchFamily="34" charset="-120"/>
               </a:rPr>
-              <a:t>[source-1] Deardorff et al., PLOS ONE 2020, doi:10.1371/journal.pone.0230697 · 第 1 页</a:t>
+              <a:t>[score] https://doi.org/10.1371/journal.pone.0230697 · PDF 5 checklist</a:t>
             </a:r>
             <a:endParaRPr lang="en-US" sz="800" dirty="0"/>
           </a:p>
@@ -3104,7 +3032,7 @@
         </p:nvSpPr>
         <p:spPr>
           <a:xfrm>
-            <a:off x="777240" y="6355080"/>
+            <a:off x="777240" y="6053328"/>
             <a:ext cx="10424160" cy="228600"/>
           </a:xfrm>
           <a:prstGeom prst="rect">
@@ -3169,10 +3097,10 @@
           <a:ln/>
         </p:spPr>
         <p:txBody>
-          <a:bodyPr wrap="square" lIns="0" tIns="0" rIns="0" bIns="0" rtlCol="0" anchor="ctr"/>
-          <a:lstStyle/>
-          <a:p>
-            <a:pPr indent="0" marL="0">
+          <a:bodyPr wrap="square" lIns="0" tIns="0" rIns="0" bIns="0" rtlCol="0" anchor="t"/>
+          <a:lstStyle/>
+          <a:p>
+            <a:pPr algn="l" indent="0" marL="0">
               <a:buNone/>
             </a:pPr>
             <a:r>
@@ -3184,7 +3112,7 @@
                 <a:ea typeface="Noto Sans CJK SC" pitchFamily="34" charset="-122"/>
                 <a:cs typeface="Noto Sans CJK SC" pitchFamily="34" charset="-120"/>
               </a:rPr>
-              <a:t>[source-1] Deardorff et al., PLOS ONE 2020, doi:10.1371/journal.pone.0230697 · 第 1 页</a:t>
+              <a:t>[open-source] https://doi.org/10.1371/journal.pone.0230697 ; https://doi.org/10.1371/journal.pone.0230697 · PDF 5 Table 1 ; PDF 5 sample</a:t>
             </a:r>
             <a:endParaRPr lang="en-US" sz="800" dirty="0"/>
           </a:p>
@@ -3308,7 +3236,7 @@
         </p:nvSpPr>
         <p:spPr>
           <a:xfrm>
-            <a:off x="777240" y="6355080"/>
+            <a:off x="777240" y="6053328"/>
             <a:ext cx="10424160" cy="228600"/>
           </a:xfrm>
           <a:prstGeom prst="rect">
@@ -3357,10 +3285,10 @@
           <a:ln/>
         </p:spPr>
         <p:txBody>
-          <a:bodyPr wrap="square" lIns="0" tIns="0" rIns="0" bIns="0" rtlCol="0" anchor="ctr"/>
-          <a:lstStyle/>
-          <a:p>
-            <a:pPr indent="0" marL="0">
+          <a:bodyPr wrap="square" lIns="0" tIns="0" rIns="0" bIns="0" rtlCol="0" anchor="t"/>
+          <a:lstStyle/>
+          <a:p>
+            <a:pPr algn="l" indent="0" marL="0">
               <a:buNone/>
             </a:pPr>
             <a:r>
@@ -3372,7 +3300,7 @@
                 <a:ea typeface="Noto Sans CJK SC" pitchFamily="34" charset="-122"/>
                 <a:cs typeface="Noto Sans CJK SC" pitchFamily="34" charset="-120"/>
               </a:rPr>
-              <a:t>[source-1] Deardorff et al., PLOS ONE 2020, doi:10.1371/journal.pone.0230697 · 第 1 页</a:t>
+              <a:t>[limitations] https://doi.org/10.1371/journal.pone.0230697 · PDF 9 limitations</a:t>
             </a:r>
             <a:endParaRPr lang="en-US" sz="800" dirty="0"/>
           </a:p>
@@ -3496,7 +3424,7 @@
         </p:nvSpPr>
         <p:spPr>
           <a:xfrm>
-            <a:off x="777240" y="6355080"/>
+            <a:off x="777240" y="6053328"/>
             <a:ext cx="10424160" cy="228600"/>
           </a:xfrm>
           <a:prstGeom prst="rect">
@@ -3545,10 +3473,10 @@
           <a:ln/>
         </p:spPr>
         <p:txBody>
-          <a:bodyPr wrap="square" lIns="0" tIns="0" rIns="0" bIns="0" rtlCol="0" anchor="ctr"/>
-          <a:lstStyle/>
-          <a:p>
-            <a:pPr indent="0" marL="0">
+          <a:bodyPr wrap="square" lIns="0" tIns="0" rIns="0" bIns="0" rtlCol="0" anchor="t"/>
+          <a:lstStyle/>
+          <a:p>
+            <a:pPr algn="l" indent="0" marL="0">
               <a:buNone/>
             </a:pPr>
             <a:r>
@@ -3560,7 +3488,7 @@
                 <a:ea typeface="Noto Sans CJK SC" pitchFamily="34" charset="-122"/>
                 <a:cs typeface="Noto Sans CJK SC" pitchFamily="34" charset="-120"/>
               </a:rPr>
-              <a:t>[source-1] Deardorff et al., PLOS ONE 2020, doi:10.1371/journal.pone.0230697 · 第 1 页</a:t>
+              <a:t>[limitations] https://doi.org/10.1371/journal.pone.0230697 · PDF 9 limitations</a:t>
             </a:r>
             <a:endParaRPr lang="en-US" sz="800" dirty="0"/>
           </a:p>

</xml_diff>